<commit_message>
test(pptx): verify shape font colour inheritance
</commit_message>
<xml_diff>
--- a/crates/pptx-parse/tests/fixtures/shape-style.pptx
+++ b/crates/pptx-parse/tests/fixtures/shape-style.pptx
@@ -3,6 +3,8 @@
 <p:presentation xmlns:a="http://schemas.openxmlformats.org/drawingml/2006/main" xmlns:r="http://schemas.openxmlformats.org/officeDocument/2006/relationships" xmlns:p="http://schemas.openxmlformats.org/presentationml/2006/main">
   <p:sldMasterIdLst>
     <p:sldMasterId id="2147483648" r:id="rId1"/>
+    <p:sldMasterId id="2147483649" r:id="rIdAuditMaster2"/>
+    <p:sldMasterId id="2147483650" r:id="rIdAuditMaster3"/>
   </p:sldMasterIdLst>
   <p:sldIdLst>
     <p:sldId id="256" r:id="rId2"/>
@@ -13,6 +15,8 @@
     <p:sldId id="261" r:id="rId7"/>
     <p:sldId id="262" r:id="rId8"/>
     <p:sldId id="263" r:id="rId9"/>
+    <p:sldId id="264" r:id="rIdAuditSlide9"/>
+    <p:sldId id="265" r:id="rIdAuditSlide10"/>
   </p:sldIdLst>
   <p:sldSz cx="12192000" cy="6858000"/>
   <p:notesSz cx="6858000" cy="9144000"/>
@@ -135,6 +139,113 @@
 </p:sldLayout>
 </file>
 
+<file path=ppt/slideLayouts/slideLayout2.xml><?xml version="1.0" encoding="utf-8"?>
+<p:sldLayout xmlns:a="http://schemas.openxmlformats.org/drawingml/2006/main" xmlns:r="http://schemas.openxmlformats.org/officeDocument/2006/relationships" xmlns:p="http://schemas.openxmlformats.org/presentationml/2006/main" type="obj">
+  <p:cSld name="Review layout">
+    <p:spTree>
+      <p:nvGrpSpPr>
+        <p:cNvPr id="1" name=""/>
+        <p:cNvGrpSpPr/>
+        <p:nvPr/>
+      </p:nvGrpSpPr>
+      <p:grpSpPr/>
+      <p:sp>
+        <p:nvSpPr>
+          <p:cNvPr id="2" name="scheme"/>
+          <p:cNvSpPr/>
+          <p:nvPr/>
+        </p:nvSpPr>
+        <p:spPr>
+          <a:xfrm>
+            <a:off x="914400" y="2200000"/>
+            <a:ext cx="5486400" cy="2200000"/>
+          </a:xfrm>
+          <a:prstGeom prst="rect">
+            <a:avLst/>
+          </a:prstGeom>
+          <a:solidFill>
+            <a:schemeClr val="accent1"/>
+          </a:solidFill>
+        </p:spPr>
+        <p:style>
+          <a:lnRef idx="2">
+            <a:schemeClr val="accent1"/>
+          </a:lnRef>
+          <a:fillRef idx="1">
+            <a:schemeClr val="accent1"/>
+          </a:fillRef>
+          <a:effectRef idx="0">
+            <a:schemeClr val="accent1"/>
+          </a:effectRef>
+          <a:fontRef idx="minor">
+            <a:schemeClr val="lt2"/>
+          </a:fontRef>
+        </p:style>
+        <p:txBody>
+          <a:bodyPr/>
+          <a:p>
+            <a:r>
+              <a:t>layout theme</a:t>
+            </a:r>
+          </a:p>
+        </p:txBody>
+      </p:sp>
+    </p:spTree>
+  </p:cSld>
+  <p:clrMapOvr>
+    <a:overrideClrMapping bg1="lt1" tx1="dk1" bg2="lt2" tx2="dk2" accent1="accent1" accent2="accent2" accent3="accent3" accent4="accent4" accent5="accent5" accent6="accent6" hlink="hlink" folHlink="folHlink"/>
+  </p:clrMapOvr>
+</p:sldLayout>
+</file>
+
+<file path=ppt/slideLayouts/slideLayout3.xml><?xml version="1.0" encoding="utf-8"?>
+<p:sldLayout xmlns:a="http://schemas.openxmlformats.org/drawingml/2006/main" xmlns:r="http://schemas.openxmlformats.org/officeDocument/2006/relationships" xmlns:p="http://schemas.openxmlformats.org/presentationml/2006/main" type="obj">
+  <p:cSld name="Review layout">
+    <p:spTree>
+      <p:nvGrpSpPr>
+        <p:cNvPr id="1" name=""/>
+        <p:cNvGrpSpPr/>
+        <p:nvPr/>
+      </p:nvGrpSpPr>
+      <p:grpSpPr/>
+      <p:sp>
+        <p:nvSpPr>
+          <p:cNvPr id="4" name="Body 2"/>
+          <p:cNvSpPr>
+            <a:spLocks noGrp="1"/>
+          </p:cNvSpPr>
+          <p:nvPr>
+            <p:ph type="body" idx="2"/>
+          </p:nvPr>
+        </p:nvSpPr>
+        <p:spPr>
+          <a:xfrm>
+            <a:off x="838200" y="1825625"/>
+            <a:ext cx="10515600" cy="4351338"/>
+          </a:xfrm>
+          <a:prstGeom prst="rect">
+            <a:avLst/>
+          </a:prstGeom>
+        </p:spPr>
+        <p:txBody>
+          <a:bodyPr/>
+          <a:lstStyle/>
+          <a:p>
+            <a:pPr>
+              <a:defRPr sz="1600"/>
+            </a:pPr>
+            <a:endParaRPr lang="en-US"/>
+          </a:p>
+        </p:txBody>
+      </p:sp>
+    </p:spTree>
+  </p:cSld>
+  <p:clrMapOvr>
+    <a:overrideClrMapping bg1="lt1" tx1="dk1" bg2="lt2" tx2="dk2" accent1="accent1" accent2="accent2" accent3="accent3" accent4="accent4" accent5="accent5" accent6="accent6" hlink="hlink" folHlink="folHlink"/>
+  </p:clrMapOvr>
+</p:sldLayout>
+</file>
+
 <file path=ppt/slideMasters/slideMaster1.xml><?xml version="1.0" encoding="utf-8"?>
 <p:sldMaster xmlns:a="http://schemas.openxmlformats.org/drawingml/2006/main" xmlns:r="http://schemas.openxmlformats.org/officeDocument/2006/relationships" xmlns:p="http://schemas.openxmlformats.org/presentationml/2006/main">
   <p:cSld>
@@ -187,6 +298,185 @@
 </p:sldMaster>
 </file>
 
+<file path=ppt/slideMasters/slideMaster2.xml><?xml version="1.0" encoding="utf-8"?>
+<p:sldMaster xmlns:a="http://schemas.openxmlformats.org/drawingml/2006/main" xmlns:r="http://schemas.openxmlformats.org/officeDocument/2006/relationships" xmlns:p="http://schemas.openxmlformats.org/presentationml/2006/main">
+  <p:cSld>
+    <p:spTree>
+      <p:nvGrpSpPr>
+        <p:cNvPr id="1" name=""/>
+        <p:cNvGrpSpPr/>
+        <p:nvPr/>
+      </p:nvGrpSpPr>
+      <p:grpSpPr/>
+      <p:sp>
+        <p:nvSpPr>
+          <p:cNvPr id="2" name="scheme"/>
+          <p:cNvSpPr/>
+          <p:nvPr/>
+        </p:nvSpPr>
+        <p:spPr>
+          <a:xfrm>
+            <a:off x="914400" y="3500000"/>
+            <a:ext cx="5486400" cy="3500000"/>
+          </a:xfrm>
+          <a:prstGeom prst="rect">
+            <a:avLst/>
+          </a:prstGeom>
+          <a:solidFill>
+            <a:schemeClr val="accent1"/>
+          </a:solidFill>
+        </p:spPr>
+        <p:style>
+          <a:lnRef idx="2">
+            <a:schemeClr val="accent1"/>
+          </a:lnRef>
+          <a:fillRef idx="1">
+            <a:schemeClr val="accent1"/>
+          </a:fillRef>
+          <a:effectRef idx="0">
+            <a:schemeClr val="accent1"/>
+          </a:effectRef>
+          <a:fontRef idx="minor">
+            <a:schemeClr val="accent2"/>
+          </a:fontRef>
+        </p:style>
+        <p:txBody>
+          <a:bodyPr/>
+          <a:p>
+            <a:r>
+              <a:t>master theme</a:t>
+            </a:r>
+          </a:p>
+        </p:txBody>
+      </p:sp>
+    </p:spTree>
+  </p:cSld>
+  <p:clrMap bg1="lt1" tx1="dk1" bg2="lt2" tx2="dk2" accent1="accent1" accent2="accent2" accent3="accent3" accent4="accent4" accent5="accent5" accent6="accent6" hlink="hlink" folHlink="folHlink"/>
+  <p:sldLayoutIdLst>
+    <p:sldLayoutId id="2147483649" r:id="rId1"/>
+  </p:sldLayoutIdLst>
+  <p:txStyles>
+    <p:titleStyle>
+      <a:lvl1pPr algn="l">
+        <a:defRPr sz="3200" b="1">
+          <a:solidFill>
+            <a:schemeClr val="dk1"/>
+          </a:solidFill>
+          <a:latin typeface="+mj-lt"/>
+        </a:defRPr>
+      </a:lvl1pPr>
+    </p:titleStyle>
+    <p:bodyStyle>
+      <a:lvl1pPr marL="342900" indent="-342900">
+        <a:buChar char="•"/>
+        <a:defRPr sz="1800">
+          <a:solidFill>
+            <a:schemeClr val="dk1"/>
+          </a:solidFill>
+          <a:latin typeface="+mn-lt"/>
+        </a:defRPr>
+      </a:lvl1pPr>
+    </p:bodyStyle>
+    <p:otherStyle>
+      <a:lvl1pPr>
+        <a:defRPr sz="1800">
+          <a:solidFill>
+            <a:srgbClr val="595959"/>
+          </a:solidFill>
+          <a:latin typeface="+mn-lt"/>
+        </a:defRPr>
+      </a:lvl1pPr>
+    </p:otherStyle>
+  </p:txStyles>
+</p:sldMaster>
+</file>
+
+<file path=ppt/slideMasters/slideMaster3.xml><?xml version="1.0" encoding="utf-8"?>
+<p:sldMaster xmlns:a="http://schemas.openxmlformats.org/drawingml/2006/main" xmlns:r="http://schemas.openxmlformats.org/officeDocument/2006/relationships" xmlns:p="http://schemas.openxmlformats.org/presentationml/2006/main">
+  <p:cSld>
+    <p:spTree>
+      <p:nvGrpSpPr>
+        <p:cNvPr id="1" name=""/>
+        <p:cNvGrpSpPr/>
+        <p:nvPr/>
+      </p:nvGrpSpPr>
+      <p:grpSpPr/>
+      <p:sp>
+        <p:nvSpPr>
+          <p:cNvPr id="4" name="Body 2"/>
+          <p:cNvSpPr>
+            <a:spLocks noGrp="1"/>
+          </p:cNvSpPr>
+          <p:nvPr>
+            <p:ph type="body" idx="2"/>
+          </p:nvPr>
+        </p:nvSpPr>
+        <p:spPr>
+          <a:xfrm>
+            <a:off x="838200" y="1825625"/>
+            <a:ext cx="10515600" cy="4351338"/>
+          </a:xfrm>
+          <a:prstGeom prst="rect">
+            <a:avLst/>
+          </a:prstGeom>
+        </p:spPr>
+        <p:txBody>
+          <a:bodyPr/>
+          <a:lstStyle/>
+          <a:p>
+            <a:pPr>
+              <a:defRPr sz="1600">
+                <a:solidFill>
+                  <a:srgbClr val="7030A0"/>
+                </a:solidFill>
+              </a:defRPr>
+            </a:pPr>
+            <a:endParaRPr lang="en-US"/>
+          </a:p>
+        </p:txBody>
+      </p:sp>
+    </p:spTree>
+  </p:cSld>
+  <p:clrMap bg1="lt1" tx1="dk1" bg2="lt2" tx2="dk2" accent1="accent1" accent2="accent2" accent3="accent3" accent4="accent4" accent5="accent5" accent6="accent6" hlink="hlink" folHlink="folHlink"/>
+  <p:sldLayoutIdLst>
+    <p:sldLayoutId id="2147483649" r:id="rId1"/>
+  </p:sldLayoutIdLst>
+  <p:txStyles>
+    <p:titleStyle>
+      <a:lvl1pPr algn="l">
+        <a:defRPr sz="3200" b="1">
+          <a:solidFill>
+            <a:schemeClr val="dk1"/>
+          </a:solidFill>
+          <a:latin typeface="+mj-lt"/>
+        </a:defRPr>
+      </a:lvl1pPr>
+    </p:titleStyle>
+    <p:bodyStyle>
+      <a:lvl1pPr marL="342900" indent="-342900">
+        <a:buChar char="•"/>
+        <a:defRPr sz="1800">
+          <a:solidFill>
+            <a:schemeClr val="dk1"/>
+          </a:solidFill>
+          <a:latin typeface="+mn-lt"/>
+        </a:defRPr>
+      </a:lvl1pPr>
+    </p:bodyStyle>
+    <p:otherStyle>
+      <a:lvl1pPr>
+        <a:defRPr sz="1800">
+          <a:solidFill>
+            <a:srgbClr val="595959"/>
+          </a:solidFill>
+          <a:latin typeface="+mn-lt"/>
+        </a:defRPr>
+      </a:lvl1pPr>
+    </p:otherStyle>
+  </p:txStyles>
+</p:sldMaster>
+</file>
+
 <file path=ppt/slides/slide1.xml><?xml version="1.0" encoding="utf-8"?>
 <p:sld xmlns:a="http://schemas.openxmlformats.org/drawingml/2006/main" xmlns:r="http://schemas.openxmlformats.org/officeDocument/2006/relationships" xmlns:p="http://schemas.openxmlformats.org/presentationml/2006/main">
   <p:cSld>
@@ -234,6 +524,96 @@
           <a:p>
             <a:r>
               <a:t>fontRef lt1</a:t>
+            </a:r>
+          </a:p>
+        </p:txBody>
+      </p:sp>
+    </p:spTree>
+  </p:cSld>
+  <p:clrMapOvr>
+    <a:masterClrMapping/>
+  </p:clrMapOvr>
+</p:sld>
+</file>
+
+<file path=ppt/slides/slide10.xml><?xml version="1.0" encoding="utf-8"?>
+<p:sld xmlns:a="http://schemas.openxmlformats.org/drawingml/2006/main" xmlns:r="http://schemas.openxmlformats.org/officeDocument/2006/relationships" xmlns:p="http://schemas.openxmlformats.org/presentationml/2006/main">
+  <p:cSld>
+    <p:spTree>
+      <p:nvGrpSpPr>
+        <p:cNvPr id="1" name=""/>
+        <p:cNvGrpSpPr/>
+        <p:nvPr/>
+      </p:nvGrpSpPr>
+      <p:grpSpPr/>
+      <p:sp>
+        <p:nvSpPr>
+          <p:cNvPr id="2" name="placeholder-default"/>
+          <p:cNvSpPr/>
+          <p:nvPr>
+            <p:ph type="body" idx="2"/>
+          </p:nvPr>
+        </p:nvSpPr>
+        <p:spPr>
+          <a:xfrm>
+            <a:off x="914400" y="914400"/>
+            <a:ext cx="5486400" cy="2743200"/>
+          </a:xfrm>
+          <a:prstGeom prst="rect">
+            <a:avLst/>
+          </a:prstGeom>
+          <a:solidFill>
+            <a:schemeClr val="accent1"/>
+          </a:solidFill>
+        </p:spPr>
+        <p:style>
+          <a:lnRef idx="2">
+            <a:schemeClr val="accent1"/>
+          </a:lnRef>
+          <a:fillRef idx="1">
+            <a:schemeClr val="accent1"/>
+          </a:fillRef>
+          <a:effectRef idx="0">
+            <a:schemeClr val="accent1"/>
+          </a:effectRef>
+          <a:fontRef idx="minor">
+            <a:schemeClr val="lt1"/>
+          </a:fontRef>
+        </p:style>
+        <p:txBody>
+          <a:bodyPr/>
+          <a:p>
+            <a:r>
+              <a:t>master placeholder</a:t>
+            </a:r>
+          </a:p>
+          <a:p>
+            <a:pPr>
+              <a:defRPr>
+                <a:solidFill>
+                  <a:srgbClr val="0070C0"/>
+                </a:solidFill>
+              </a:defRPr>
+            </a:pPr>
+            <a:r>
+              <a:t>paragraph default</a:t>
+            </a:r>
+          </a:p>
+          <a:p>
+            <a:pPr>
+              <a:defRPr>
+                <a:solidFill>
+                  <a:srgbClr val="0070C0"/>
+                </a:solidFill>
+              </a:defRPr>
+            </a:pPr>
+            <a:r>
+              <a:rPr>
+                <a:solidFill>
+                  <a:srgbClr val="00B050"/>
+                </a:solidFill>
+              </a:rPr>
+              <a:t>explicit run</a:t>
             </a:r>
           </a:p>
         </p:txBody>
@@ -647,6 +1027,65 @@
           <a:p>
             <a:r>
               <a:t>layout body without colour</a:t>
+            </a:r>
+          </a:p>
+        </p:txBody>
+      </p:sp>
+    </p:spTree>
+  </p:cSld>
+  <p:clrMapOvr>
+    <a:masterClrMapping/>
+  </p:clrMapOvr>
+</p:sld>
+</file>
+
+<file path=ppt/slides/slide9.xml><?xml version="1.0" encoding="utf-8"?>
+<p:sld xmlns:a="http://schemas.openxmlformats.org/drawingml/2006/main" xmlns:r="http://schemas.openxmlformats.org/officeDocument/2006/relationships" xmlns:p="http://schemas.openxmlformats.org/presentationml/2006/main">
+  <p:cSld>
+    <p:spTree>
+      <p:nvGrpSpPr>
+        <p:cNvPr id="1" name=""/>
+        <p:cNvGrpSpPr/>
+        <p:nvPr/>
+      </p:nvGrpSpPr>
+      <p:grpSpPr/>
+      <p:sp>
+        <p:nvSpPr>
+          <p:cNvPr id="2" name="scheme"/>
+          <p:cNvSpPr/>
+          <p:nvPr/>
+        </p:nvSpPr>
+        <p:spPr>
+          <a:xfrm>
+            <a:off x="914400" y="914400"/>
+            <a:ext cx="5486400" cy="914400"/>
+          </a:xfrm>
+          <a:prstGeom prst="rect">
+            <a:avLst/>
+          </a:prstGeom>
+          <a:solidFill>
+            <a:schemeClr val="accent1"/>
+          </a:solidFill>
+        </p:spPr>
+        <p:style>
+          <a:lnRef idx="2">
+            <a:schemeClr val="accent1"/>
+          </a:lnRef>
+          <a:fillRef idx="1">
+            <a:schemeClr val="accent1"/>
+          </a:fillRef>
+          <a:effectRef idx="0">
+            <a:schemeClr val="accent1"/>
+          </a:effectRef>
+          <a:fontRef idx="minor">
+            <a:schemeClr val="lt1"/>
+          </a:fontRef>
+        </p:style>
+        <p:txBody>
+          <a:bodyPr/>
+          <a:p>
+            <a:r>
+              <a:t>second theme</a:t>
             </a:r>
           </a:p>
         </p:txBody>
@@ -766,4 +1205,113 @@
     </a:fmtScheme>
   </a:themeElements>
 </a:theme>
+</file>
+
+<file path=ppt/theme/theme2.xml><?xml version="1.0" encoding="utf-8"?>
+<a:theme xmlns:a="http://schemas.openxmlformats.org/drawingml/2006/main" name="Review">
+  <a:themeElements>
+    <a:clrScheme name="Review">
+      <a:dk1>
+        <a:sysClr val="windowText" lastClr="000000"/>
+      </a:dk1>
+      <a:lt1>
+        <a:srgbClr val="123456"/>
+      </a:lt1>
+      <a:dk2>
+        <a:srgbClr val="44546A"/>
+      </a:dk2>
+      <a:lt2>
+        <a:srgbClr val="234567"/>
+      </a:lt2>
+      <a:accent1>
+        <a:srgbClr val="4472C4"/>
+      </a:accent1>
+      <a:accent2>
+        <a:srgbClr val="345678"/>
+      </a:accent2>
+      <a:accent3>
+        <a:srgbClr val="A5A5A5"/>
+      </a:accent3>
+      <a:accent4>
+        <a:srgbClr val="FFC000"/>
+      </a:accent4>
+      <a:accent5>
+        <a:srgbClr val="5B9BD5"/>
+      </a:accent5>
+      <a:accent6>
+        <a:srgbClr val="70AD47"/>
+      </a:accent6>
+      <a:hlink>
+        <a:srgbClr val="0563C1"/>
+      </a:hlink>
+      <a:folHlink>
+        <a:srgbClr val="954F72"/>
+      </a:folHlink>
+    </a:clrScheme>
+    <a:fontScheme name="Review">
+      <a:majorFont>
+        <a:latin typeface="Calibri Light"/>
+        <a:ea typeface=""/>
+        <a:cs typeface=""/>
+      </a:majorFont>
+      <a:minorFont>
+        <a:latin typeface="Calibri"/>
+        <a:ea typeface=""/>
+        <a:cs typeface=""/>
+      </a:minorFont>
+    </a:fontScheme>
+    <a:fmtScheme name="Review">
+      <a:fillStyleLst>
+        <a:solidFill>
+          <a:schemeClr val="phClr"/>
+        </a:solidFill>
+        <a:solidFill>
+          <a:schemeClr val="phClr"/>
+        </a:solidFill>
+        <a:solidFill>
+          <a:schemeClr val="phClr"/>
+        </a:solidFill>
+      </a:fillStyleLst>
+      <a:lnStyleLst>
+        <a:ln w="6350">
+          <a:solidFill>
+            <a:schemeClr val="phClr"/>
+          </a:solidFill>
+        </a:ln>
+        <a:ln w="12700">
+          <a:solidFill>
+            <a:schemeClr val="phClr"/>
+          </a:solidFill>
+        </a:ln>
+        <a:ln w="19050">
+          <a:solidFill>
+            <a:schemeClr val="phClr"/>
+          </a:solidFill>
+        </a:ln>
+      </a:lnStyleLst>
+      <a:effectStyleLst>
+        <a:effectStyle>
+          <a:effectLst/>
+        </a:effectStyle>
+        <a:effectStyle>
+          <a:effectLst/>
+        </a:effectStyle>
+        <a:effectStyle>
+          <a:effectLst/>
+        </a:effectStyle>
+      </a:effectStyleLst>
+      <a:bgFillStyleLst>
+        <a:solidFill>
+          <a:schemeClr val="phClr"/>
+        </a:solidFill>
+        <a:solidFill>
+          <a:schemeClr val="phClr"/>
+        </a:solidFill>
+        <a:solidFill>
+          <a:schemeClr val="phClr"/>
+        </a:solidFill>
+      </a:bgFillStyleLst>
+    </a:fmtScheme>
+  </a:themeElements>
+</a:theme>
 </file>
</xml_diff>